<commit_message>
Update RV32I Pipeline Midterm.pptx
</commit_message>
<xml_diff>
--- a/Report/RV32I Pipeline Midterm.pptx
+++ b/Report/RV32I Pipeline Midterm.pptx
@@ -145,6 +145,178 @@
 </p:presentation>
 </file>
 
+<file path=ppt/changesInfos/changesInfo1.xml><?xml version="1.0" encoding="utf-8"?>
+<pc:chgInfo xmlns:a="http://schemas.openxmlformats.org/drawingml/2006/main" xmlns:r="http://schemas.openxmlformats.org/officeDocument/2006/relationships" xmlns:ac="http://schemas.microsoft.com/office/drawing/2013/main/command" xmlns:pc="http://schemas.microsoft.com/office/powerpoint/2013/main/command">
+  <pc:docChgLst>
+    <pc:chgData name="Kantaphon Kitsanakarakat" userId="34fbd52d53948f28" providerId="LiveId" clId="{2ACBE802-F97E-4423-8328-9FB178187958}"/>
+    <pc:docChg chg="custSel modSld">
+      <pc:chgData name="Kantaphon Kitsanakarakat" userId="34fbd52d53948f28" providerId="LiveId" clId="{2ACBE802-F97E-4423-8328-9FB178187958}" dt="2026-09-09T12:30:44.872" v="53" actId="1076"/>
+      <pc:docMkLst>
+        <pc:docMk/>
+      </pc:docMkLst>
+      <pc:sldChg chg="addSp delSp modSp mod">
+        <pc:chgData name="Kantaphon Kitsanakarakat" userId="34fbd52d53948f28" providerId="LiveId" clId="{2ACBE802-F97E-4423-8328-9FB178187958}" dt="2026-09-09T12:30:06.669" v="47" actId="1076"/>
+        <pc:sldMkLst>
+          <pc:docMk/>
+          <pc:sldMk cId="0" sldId="272"/>
+        </pc:sldMkLst>
+        <pc:spChg chg="del">
+          <ac:chgData name="Kantaphon Kitsanakarakat" userId="34fbd52d53948f28" providerId="LiveId" clId="{2ACBE802-F97E-4423-8328-9FB178187958}" dt="2026-09-09T12:28:34.142" v="5" actId="478"/>
+          <ac:spMkLst>
+            <pc:docMk/>
+            <pc:sldMk cId="0" sldId="272"/>
+            <ac:spMk id="58" creationId="{00000000-0000-0000-0000-000000000000}"/>
+          </ac:spMkLst>
+        </pc:spChg>
+        <pc:spChg chg="del">
+          <ac:chgData name="Kantaphon Kitsanakarakat" userId="34fbd52d53948f28" providerId="LiveId" clId="{2ACBE802-F97E-4423-8328-9FB178187958}" dt="2026-09-09T12:28:37.983" v="7" actId="478"/>
+          <ac:spMkLst>
+            <pc:docMk/>
+            <pc:sldMk cId="0" sldId="272"/>
+            <ac:spMk id="59" creationId="{00000000-0000-0000-0000-000000000000}"/>
+          </ac:spMkLst>
+        </pc:spChg>
+        <pc:spChg chg="del mod">
+          <ac:chgData name="Kantaphon Kitsanakarakat" userId="34fbd52d53948f28" providerId="LiveId" clId="{2ACBE802-F97E-4423-8328-9FB178187958}" dt="2026-09-09T12:28:40.873" v="11" actId="478"/>
+          <ac:spMkLst>
+            <pc:docMk/>
+            <pc:sldMk cId="0" sldId="272"/>
+            <ac:spMk id="60" creationId="{00000000-0000-0000-0000-000000000000}"/>
+          </ac:spMkLst>
+        </pc:spChg>
+        <pc:spChg chg="del">
+          <ac:chgData name="Kantaphon Kitsanakarakat" userId="34fbd52d53948f28" providerId="LiveId" clId="{2ACBE802-F97E-4423-8328-9FB178187958}" dt="2026-09-09T12:28:36.793" v="6" actId="478"/>
+          <ac:spMkLst>
+            <pc:docMk/>
+            <pc:sldMk cId="0" sldId="272"/>
+            <ac:spMk id="61" creationId="{00000000-0000-0000-0000-000000000000}"/>
+          </ac:spMkLst>
+        </pc:spChg>
+        <pc:spChg chg="del">
+          <ac:chgData name="Kantaphon Kitsanakarakat" userId="34fbd52d53948f28" providerId="LiveId" clId="{2ACBE802-F97E-4423-8328-9FB178187958}" dt="2026-09-09T12:28:41.448" v="12" actId="478"/>
+          <ac:spMkLst>
+            <pc:docMk/>
+            <pc:sldMk cId="0" sldId="272"/>
+            <ac:spMk id="62" creationId="{00000000-0000-0000-0000-000000000000}"/>
+          </ac:spMkLst>
+        </pc:spChg>
+        <pc:spChg chg="del mod">
+          <ac:chgData name="Kantaphon Kitsanakarakat" userId="34fbd52d53948f28" providerId="LiveId" clId="{2ACBE802-F97E-4423-8328-9FB178187958}" dt="2026-09-09T12:28:43.293" v="14" actId="478"/>
+          <ac:spMkLst>
+            <pc:docMk/>
+            <pc:sldMk cId="0" sldId="272"/>
+            <ac:spMk id="63" creationId="{00000000-0000-0000-0000-000000000000}"/>
+          </ac:spMkLst>
+        </pc:spChg>
+        <pc:picChg chg="add mod">
+          <ac:chgData name="Kantaphon Kitsanakarakat" userId="34fbd52d53948f28" providerId="LiveId" clId="{2ACBE802-F97E-4423-8328-9FB178187958}" dt="2026-09-09T12:30:06.669" v="47" actId="1076"/>
+          <ac:picMkLst>
+            <pc:docMk/>
+            <pc:sldMk cId="0" sldId="272"/>
+            <ac:picMk id="68" creationId="{9AB61EF2-AF7D-8E7A-8477-2A05A1E6EC47}"/>
+          </ac:picMkLst>
+        </pc:picChg>
+        <pc:picChg chg="add del mod">
+          <ac:chgData name="Kantaphon Kitsanakarakat" userId="34fbd52d53948f28" providerId="LiveId" clId="{2ACBE802-F97E-4423-8328-9FB178187958}" dt="2026-09-09T12:28:56.035" v="20" actId="478"/>
+          <ac:picMkLst>
+            <pc:docMk/>
+            <pc:sldMk cId="0" sldId="272"/>
+            <ac:picMk id="70" creationId="{0424E62B-B9FB-B217-02E3-F0C4D7C11FA4}"/>
+          </ac:picMkLst>
+        </pc:picChg>
+        <pc:picChg chg="add del mod">
+          <ac:chgData name="Kantaphon Kitsanakarakat" userId="34fbd52d53948f28" providerId="LiveId" clId="{2ACBE802-F97E-4423-8328-9FB178187958}" dt="2026-09-09T12:28:56.035" v="20" actId="478"/>
+          <ac:picMkLst>
+            <pc:docMk/>
+            <pc:sldMk cId="0" sldId="272"/>
+            <ac:picMk id="72" creationId="{22A90903-B7AA-070C-F4B2-8074D3761A0A}"/>
+          </ac:picMkLst>
+        </pc:picChg>
+        <pc:picChg chg="add mod">
+          <ac:chgData name="Kantaphon Kitsanakarakat" userId="34fbd52d53948f28" providerId="LiveId" clId="{2ACBE802-F97E-4423-8328-9FB178187958}" dt="2026-09-09T12:29:42.024" v="40" actId="1076"/>
+          <ac:picMkLst>
+            <pc:docMk/>
+            <pc:sldMk cId="0" sldId="272"/>
+            <ac:picMk id="74" creationId="{804E78F1-0755-4C33-258B-5032E4EC100F}"/>
+          </ac:picMkLst>
+        </pc:picChg>
+        <pc:picChg chg="add mod">
+          <ac:chgData name="Kantaphon Kitsanakarakat" userId="34fbd52d53948f28" providerId="LiveId" clId="{2ACBE802-F97E-4423-8328-9FB178187958}" dt="2026-09-09T12:29:38.798" v="39" actId="1076"/>
+          <ac:picMkLst>
+            <pc:docMk/>
+            <pc:sldMk cId="0" sldId="272"/>
+            <ac:picMk id="76" creationId="{4DC81C44-7678-57AD-FC8E-90B49F93D432}"/>
+          </ac:picMkLst>
+        </pc:picChg>
+      </pc:sldChg>
+      <pc:sldChg chg="addSp delSp modSp mod">
+        <pc:chgData name="Kantaphon Kitsanakarakat" userId="34fbd52d53948f28" providerId="LiveId" clId="{2ACBE802-F97E-4423-8328-9FB178187958}" dt="2026-09-09T12:30:44.872" v="53" actId="1076"/>
+        <pc:sldMkLst>
+          <pc:docMk/>
+          <pc:sldMk cId="0" sldId="274"/>
+        </pc:sldMkLst>
+        <pc:spChg chg="del">
+          <ac:chgData name="Kantaphon Kitsanakarakat" userId="34fbd52d53948f28" providerId="LiveId" clId="{2ACBE802-F97E-4423-8328-9FB178187958}" dt="2026-09-09T12:30:30.232" v="48" actId="478"/>
+          <ac:spMkLst>
+            <pc:docMk/>
+            <pc:sldMk cId="0" sldId="274"/>
+            <ac:spMk id="16" creationId="{00000000-0000-0000-0000-000000000000}"/>
+          </ac:spMkLst>
+        </pc:spChg>
+        <pc:spChg chg="del">
+          <ac:chgData name="Kantaphon Kitsanakarakat" userId="34fbd52d53948f28" providerId="LiveId" clId="{2ACBE802-F97E-4423-8328-9FB178187958}" dt="2026-09-09T12:30:30.232" v="48" actId="478"/>
+          <ac:spMkLst>
+            <pc:docMk/>
+            <pc:sldMk cId="0" sldId="274"/>
+            <ac:spMk id="17" creationId="{00000000-0000-0000-0000-000000000000}"/>
+          </ac:spMkLst>
+        </pc:spChg>
+        <pc:spChg chg="del">
+          <ac:chgData name="Kantaphon Kitsanakarakat" userId="34fbd52d53948f28" providerId="LiveId" clId="{2ACBE802-F97E-4423-8328-9FB178187958}" dt="2026-09-09T12:30:30.232" v="48" actId="478"/>
+          <ac:spMkLst>
+            <pc:docMk/>
+            <pc:sldMk cId="0" sldId="274"/>
+            <ac:spMk id="18" creationId="{00000000-0000-0000-0000-000000000000}"/>
+          </ac:spMkLst>
+        </pc:spChg>
+        <pc:spChg chg="del">
+          <ac:chgData name="Kantaphon Kitsanakarakat" userId="34fbd52d53948f28" providerId="LiveId" clId="{2ACBE802-F97E-4423-8328-9FB178187958}" dt="2026-09-09T12:30:30.232" v="48" actId="478"/>
+          <ac:spMkLst>
+            <pc:docMk/>
+            <pc:sldMk cId="0" sldId="274"/>
+            <ac:spMk id="19" creationId="{00000000-0000-0000-0000-000000000000}"/>
+          </ac:spMkLst>
+        </pc:spChg>
+        <pc:spChg chg="del">
+          <ac:chgData name="Kantaphon Kitsanakarakat" userId="34fbd52d53948f28" providerId="LiveId" clId="{2ACBE802-F97E-4423-8328-9FB178187958}" dt="2026-09-09T12:30:30.232" v="48" actId="478"/>
+          <ac:spMkLst>
+            <pc:docMk/>
+            <pc:sldMk cId="0" sldId="274"/>
+            <ac:spMk id="20" creationId="{00000000-0000-0000-0000-000000000000}"/>
+          </ac:spMkLst>
+        </pc:spChg>
+        <pc:spChg chg="del">
+          <ac:chgData name="Kantaphon Kitsanakarakat" userId="34fbd52d53948f28" providerId="LiveId" clId="{2ACBE802-F97E-4423-8328-9FB178187958}" dt="2026-09-09T12:30:30.232" v="48" actId="478"/>
+          <ac:spMkLst>
+            <pc:docMk/>
+            <pc:sldMk cId="0" sldId="274"/>
+            <ac:spMk id="21" creationId="{00000000-0000-0000-0000-000000000000}"/>
+          </ac:spMkLst>
+        </pc:spChg>
+        <pc:picChg chg="add mod">
+          <ac:chgData name="Kantaphon Kitsanakarakat" userId="34fbd52d53948f28" providerId="LiveId" clId="{2ACBE802-F97E-4423-8328-9FB178187958}" dt="2026-09-09T12:30:44.872" v="53" actId="1076"/>
+          <ac:picMkLst>
+            <pc:docMk/>
+            <pc:sldMk cId="0" sldId="274"/>
+            <ac:picMk id="42" creationId="{86819F9E-36F6-3EFA-BCB8-C692F54D6EF6}"/>
+          </ac:picMkLst>
+        </pc:picChg>
+      </pc:sldChg>
+    </pc:docChg>
+  </pc:docChgLst>
+</pc:chgInfo>
+</file>
+
 <file path=ppt/slideLayouts/slideLayout1.xml><?xml version="1.0" encoding="utf-8"?>
 <p:sldLayout xmlns:a="http://schemas.openxmlformats.org/drawingml/2006/main" xmlns:r="http://schemas.openxmlformats.org/officeDocument/2006/relationships" xmlns:p="http://schemas.openxmlformats.org/presentationml/2006/main" type="title" preserve="1">
   <p:cSld name="Title Slide">
@@ -324,7 +496,7 @@
           <a:p>
             <a:fld id="{5BCAD085-E8A6-8845-BD4E-CB4CCA059FC4}" type="datetimeFigureOut">
               <a:rPr lang="en-US" smtClean="0"/>
-              <a:t>9/9/26</a:t>
+              <a:t>9/9/2026</a:t>
             </a:fld>
             <a:endParaRPr lang="en-US"/>
           </a:p>
@@ -492,7 +664,7 @@
           <a:p>
             <a:fld id="{5BCAD085-E8A6-8845-BD4E-CB4CCA059FC4}" type="datetimeFigureOut">
               <a:rPr lang="en-US" smtClean="0"/>
-              <a:t>9/9/26</a:t>
+              <a:t>9/9/2026</a:t>
             </a:fld>
             <a:endParaRPr lang="en-US"/>
           </a:p>
@@ -670,7 +842,7 @@
           <a:p>
             <a:fld id="{5BCAD085-E8A6-8845-BD4E-CB4CCA059FC4}" type="datetimeFigureOut">
               <a:rPr lang="en-US" smtClean="0"/>
-              <a:t>9/9/26</a:t>
+              <a:t>9/9/2026</a:t>
             </a:fld>
             <a:endParaRPr lang="en-US"/>
           </a:p>
@@ -838,7 +1010,7 @@
           <a:p>
             <a:fld id="{5BCAD085-E8A6-8845-BD4E-CB4CCA059FC4}" type="datetimeFigureOut">
               <a:rPr lang="en-US" smtClean="0"/>
-              <a:t>9/9/26</a:t>
+              <a:t>9/9/2026</a:t>
             </a:fld>
             <a:endParaRPr lang="en-US"/>
           </a:p>
@@ -1083,7 +1255,7 @@
           <a:p>
             <a:fld id="{5BCAD085-E8A6-8845-BD4E-CB4CCA059FC4}" type="datetimeFigureOut">
               <a:rPr lang="en-US" smtClean="0"/>
-              <a:t>9/9/26</a:t>
+              <a:t>9/9/2026</a:t>
             </a:fld>
             <a:endParaRPr lang="en-US"/>
           </a:p>
@@ -1368,7 +1540,7 @@
           <a:p>
             <a:fld id="{5BCAD085-E8A6-8845-BD4E-CB4CCA059FC4}" type="datetimeFigureOut">
               <a:rPr lang="en-US" smtClean="0"/>
-              <a:t>9/9/26</a:t>
+              <a:t>9/9/2026</a:t>
             </a:fld>
             <a:endParaRPr lang="en-US"/>
           </a:p>
@@ -1787,7 +1959,7 @@
           <a:p>
             <a:fld id="{5BCAD085-E8A6-8845-BD4E-CB4CCA059FC4}" type="datetimeFigureOut">
               <a:rPr lang="en-US" smtClean="0"/>
-              <a:t>9/9/26</a:t>
+              <a:t>9/9/2026</a:t>
             </a:fld>
             <a:endParaRPr lang="en-US"/>
           </a:p>
@@ -1904,7 +2076,7 @@
           <a:p>
             <a:fld id="{5BCAD085-E8A6-8845-BD4E-CB4CCA059FC4}" type="datetimeFigureOut">
               <a:rPr lang="en-US" smtClean="0"/>
-              <a:t>9/9/26</a:t>
+              <a:t>9/9/2026</a:t>
             </a:fld>
             <a:endParaRPr lang="en-US"/>
           </a:p>
@@ -1999,7 +2171,7 @@
           <a:p>
             <a:fld id="{5BCAD085-E8A6-8845-BD4E-CB4CCA059FC4}" type="datetimeFigureOut">
               <a:rPr lang="en-US" smtClean="0"/>
-              <a:t>9/9/26</a:t>
+              <a:t>9/9/2026</a:t>
             </a:fld>
             <a:endParaRPr lang="en-US"/>
           </a:p>
@@ -2274,7 +2446,7 @@
           <a:p>
             <a:fld id="{5BCAD085-E8A6-8845-BD4E-CB4CCA059FC4}" type="datetimeFigureOut">
               <a:rPr lang="en-US" smtClean="0"/>
-              <a:t>9/9/26</a:t>
+              <a:t>9/9/2026</a:t>
             </a:fld>
             <a:endParaRPr lang="en-US"/>
           </a:p>
@@ -2526,7 +2698,7 @@
           <a:p>
             <a:fld id="{5BCAD085-E8A6-8845-BD4E-CB4CCA059FC4}" type="datetimeFigureOut">
               <a:rPr lang="en-US" smtClean="0"/>
-              <a:t>9/9/26</a:t>
+              <a:t>9/9/2026</a:t>
             </a:fld>
             <a:endParaRPr lang="en-US"/>
           </a:p>
@@ -2737,7 +2909,7 @@
           <a:p>
             <a:fld id="{5BCAD085-E8A6-8845-BD4E-CB4CCA059FC4}" type="datetimeFigureOut">
               <a:rPr lang="en-US" smtClean="0"/>
-              <a:t>9/9/26</a:t>
+              <a:t>9/9/2026</a:t>
             </a:fld>
             <a:endParaRPr lang="en-US"/>
           </a:p>
@@ -28841,278 +29013,6 @@
           </a:fontRef>
         </p:style>
       </p:cxnSp>
-      <p:sp>
-        <p:nvSpPr>
-          <p:cNvPr id="58" name="Rectangle 57"/>
-          <p:cNvSpPr/>
-          <p:nvPr/>
-        </p:nvSpPr>
-        <p:spPr>
-          <a:xfrm>
-            <a:off x="6279184" y="1783080"/>
-            <a:ext cx="5303520" cy="4160520"/>
-          </a:xfrm>
-          <a:prstGeom prst="rect">
-            <a:avLst/>
-          </a:prstGeom>
-          <a:solidFill>
-            <a:srgbClr val="EFE2CC"/>
-          </a:solidFill>
-          <a:ln w="19050">
-            <a:solidFill>
-              <a:srgbClr val="9A6410"/>
-            </a:solidFill>
-          </a:ln>
-          <a:effectLst/>
-        </p:spPr>
-        <p:style>
-          <a:lnRef idx="1">
-            <a:schemeClr val="accent1"/>
-          </a:lnRef>
-          <a:fillRef idx="3">
-            <a:schemeClr val="accent1"/>
-          </a:fillRef>
-          <a:effectRef idx="2">
-            <a:schemeClr val="accent1"/>
-          </a:effectRef>
-          <a:fontRef idx="minor">
-            <a:schemeClr val="lt1"/>
-          </a:fontRef>
-        </p:style>
-        <p:txBody>
-          <a:bodyPr rtlCol="0" anchor="ctr"/>
-          <a:lstStyle/>
-          <a:p>
-            <a:pPr algn="ctr"/>
-            <a:endParaRPr/>
-          </a:p>
-        </p:txBody>
-      </p:sp>
-      <p:sp>
-        <p:nvSpPr>
-          <p:cNvPr id="59" name="Rectangle 58"/>
-          <p:cNvSpPr/>
-          <p:nvPr/>
-        </p:nvSpPr>
-        <p:spPr>
-          <a:xfrm>
-            <a:off x="8272576" y="2057400"/>
-            <a:ext cx="1316736" cy="237744"/>
-          </a:xfrm>
-          <a:prstGeom prst="rect">
-            <a:avLst/>
-          </a:prstGeom>
-          <a:noFill/>
-          <a:ln w="12700">
-            <a:solidFill>
-              <a:srgbClr val="9A6410"/>
-            </a:solidFill>
-          </a:ln>
-          <a:effectLst/>
-        </p:spPr>
-        <p:style>
-          <a:lnRef idx="1">
-            <a:schemeClr val="accent1"/>
-          </a:lnRef>
-          <a:fillRef idx="3">
-            <a:schemeClr val="accent1"/>
-          </a:fillRef>
-          <a:effectRef idx="2">
-            <a:schemeClr val="accent1"/>
-          </a:effectRef>
-          <a:fontRef idx="minor">
-            <a:schemeClr val="lt1"/>
-          </a:fontRef>
-        </p:style>
-        <p:txBody>
-          <a:bodyPr wrap="square" lIns="0" tIns="0" rIns="0" bIns="0" rtlCol="0" anchor="ctr"/>
-          <a:lstStyle/>
-          <a:p>
-            <a:pPr algn="ctr"/>
-            <a:r>
-              <a:rPr sz="700" b="1">
-                <a:solidFill>
-                  <a:srgbClr val="9A6410"/>
-                </a:solidFill>
-                <a:latin typeface="Consolas"/>
-              </a:rPr>
-              <a:t>CAPTURE REQUIRED</a:t>
-            </a:r>
-          </a:p>
-        </p:txBody>
-      </p:sp>
-      <p:sp>
-        <p:nvSpPr>
-          <p:cNvPr id="60" name="TextBox 59"/>
-          <p:cNvSpPr txBox="1"/>
-          <p:nvPr/>
-        </p:nvSpPr>
-        <p:spPr>
-          <a:xfrm>
-            <a:off x="6644944" y="2478024"/>
-            <a:ext cx="4572000" cy="457200"/>
-          </a:xfrm>
-          <a:prstGeom prst="rect">
-            <a:avLst/>
-          </a:prstGeom>
-          <a:noFill/>
-        </p:spPr>
-        <p:txBody>
-          <a:bodyPr wrap="square" lIns="0" tIns="0" rIns="0" bIns="0" anchor="t">
-            <a:spAutoFit/>
-          </a:bodyPr>
-          <a:lstStyle/>
-          <a:p>
-            <a:pPr algn="ctr">
-              <a:lnSpc>
-                <a:spcPct val="120000"/>
-              </a:lnSpc>
-            </a:pPr>
-            <a:r>
-              <a:rPr sz="1350" b="1">
-                <a:solidFill>
-                  <a:srgbClr val="2A2419"/>
-                </a:solidFill>
-                <a:latin typeface="Arial"/>
-              </a:rPr>
-              <a:t>The regression summary table, straight from the console</a:t>
-            </a:r>
-          </a:p>
-        </p:txBody>
-      </p:sp>
-      <p:sp>
-        <p:nvSpPr>
-          <p:cNvPr id="61" name="TextBox 60"/>
-          <p:cNvSpPr txBox="1"/>
-          <p:nvPr/>
-        </p:nvSpPr>
-        <p:spPr>
-          <a:xfrm>
-            <a:off x="6736384" y="3044952"/>
-            <a:ext cx="4389120" cy="914400"/>
-          </a:xfrm>
-          <a:prstGeom prst="rect">
-            <a:avLst/>
-          </a:prstGeom>
-          <a:noFill/>
-        </p:spPr>
-        <p:txBody>
-          <a:bodyPr wrap="square" lIns="0" tIns="0" rIns="0" bIns="0" anchor="t">
-            <a:spAutoFit/>
-          </a:bodyPr>
-          <a:lstStyle/>
-          <a:p>
-            <a:pPr algn="ctr">
-              <a:lnSpc>
-                <a:spcPct val="135000"/>
-              </a:lnSpc>
-            </a:pPr>
-            <a:r>
-              <a:rPr sz="1000" b="0">
-                <a:solidFill>
-                  <a:srgbClr val="655C4C"/>
-                </a:solidFill>
-                <a:latin typeface="Arial"/>
-              </a:rPr>
-              <a:t>Run on the Windows machine and screenshot the whole summary block: the per-program PASS lines plus the TOTAL row with cycles, instructions, stalls, flushes and CPI. It is the slide that shows the results came from a tool rather than a typed-up table.</a:t>
-            </a:r>
-          </a:p>
-        </p:txBody>
-      </p:sp>
-      <p:sp>
-        <p:nvSpPr>
-          <p:cNvPr id="62" name="Rectangle 61"/>
-          <p:cNvSpPr/>
-          <p:nvPr/>
-        </p:nvSpPr>
-        <p:spPr>
-          <a:xfrm>
-            <a:off x="6599224" y="3886200"/>
-            <a:ext cx="4663440" cy="310896"/>
-          </a:xfrm>
-          <a:prstGeom prst="rect">
-            <a:avLst/>
-          </a:prstGeom>
-          <a:solidFill>
-            <a:srgbClr val="F7F3E8"/>
-          </a:solidFill>
-          <a:ln w="9525">
-            <a:solidFill>
-              <a:srgbClr val="D2C7AF"/>
-            </a:solidFill>
-          </a:ln>
-          <a:effectLst/>
-        </p:spPr>
-        <p:style>
-          <a:lnRef idx="1">
-            <a:schemeClr val="accent1"/>
-          </a:lnRef>
-          <a:fillRef idx="3">
-            <a:schemeClr val="accent1"/>
-          </a:fillRef>
-          <a:effectRef idx="2">
-            <a:schemeClr val="accent1"/>
-          </a:effectRef>
-          <a:fontRef idx="minor">
-            <a:schemeClr val="lt1"/>
-          </a:fontRef>
-        </p:style>
-        <p:txBody>
-          <a:bodyPr wrap="square" lIns="0" tIns="0" rIns="0" bIns="0" rtlCol="0" anchor="ctr"/>
-          <a:lstStyle/>
-          <a:p>
-            <a:pPr algn="ctr"/>
-            <a:r>
-              <a:rPr sz="850" b="0">
-                <a:solidFill>
-                  <a:srgbClr val="2A2419"/>
-                </a:solidFill>
-                <a:latin typeface="Consolas"/>
-              </a:rPr>
-              <a:t>python tools/run_tests.py --dir asm/prog</a:t>
-            </a:r>
-          </a:p>
-        </p:txBody>
-      </p:sp>
-      <p:sp>
-        <p:nvSpPr>
-          <p:cNvPr id="63" name="TextBox 62"/>
-          <p:cNvSpPr txBox="1"/>
-          <p:nvPr/>
-        </p:nvSpPr>
-        <p:spPr>
-          <a:xfrm>
-            <a:off x="6644944" y="4306824"/>
-            <a:ext cx="4572000" cy="365760"/>
-          </a:xfrm>
-          <a:prstGeom prst="rect">
-            <a:avLst/>
-          </a:prstGeom>
-          <a:noFill/>
-        </p:spPr>
-        <p:txBody>
-          <a:bodyPr wrap="square" lIns="0" tIns="0" rIns="0" bIns="0" anchor="t">
-            <a:spAutoFit/>
-          </a:bodyPr>
-          <a:lstStyle/>
-          <a:p>
-            <a:pPr algn="ctr">
-              <a:lnSpc>
-                <a:spcPct val="130000"/>
-              </a:lnSpc>
-            </a:pPr>
-            <a:r>
-              <a:rPr sz="900" b="0">
-                <a:solidFill>
-                  <a:srgbClr val="655C4C"/>
-                </a:solidFill>
-                <a:latin typeface="Arial"/>
-              </a:rPr>
-              <a:t>Crop tight to the table. A dark terminal is fine.</a:t>
-            </a:r>
-          </a:p>
-        </p:txBody>
-      </p:sp>
       <p:cxnSp>
         <p:nvCxnSpPr>
           <p:cNvPr id="64" name="Connector 63"/>
@@ -29250,6 +29150,96 @@
           </a:p>
         </p:txBody>
       </p:sp>
+      <p:pic>
+        <p:nvPicPr>
+          <p:cNvPr id="68" name="Picture 67">
+            <a:extLst>
+              <a:ext uri="{FF2B5EF4-FFF2-40B4-BE49-F238E27FC236}">
+                <a16:creationId xmlns:a16="http://schemas.microsoft.com/office/drawing/2014/main" id="{9AB61EF2-AF7D-8E7A-8477-2A05A1E6EC47}"/>
+              </a:ext>
+            </a:extLst>
+          </p:cNvPr>
+          <p:cNvPicPr>
+            <a:picLocks noChangeAspect="1"/>
+          </p:cNvPicPr>
+          <p:nvPr/>
+        </p:nvPicPr>
+        <p:blipFill>
+          <a:blip r:embed="rId2"/>
+          <a:stretch>
+            <a:fillRect/>
+          </a:stretch>
+        </p:blipFill>
+        <p:spPr>
+          <a:xfrm>
+            <a:off x="6187138" y="728777"/>
+            <a:ext cx="3225364" cy="2500958"/>
+          </a:xfrm>
+          <a:prstGeom prst="rect">
+            <a:avLst/>
+          </a:prstGeom>
+        </p:spPr>
+      </p:pic>
+      <p:pic>
+        <p:nvPicPr>
+          <p:cNvPr id="74" name="Picture 73">
+            <a:extLst>
+              <a:ext uri="{FF2B5EF4-FFF2-40B4-BE49-F238E27FC236}">
+                <a16:creationId xmlns:a16="http://schemas.microsoft.com/office/drawing/2014/main" id="{804E78F1-0755-4C33-258B-5032E4EC100F}"/>
+              </a:ext>
+            </a:extLst>
+          </p:cNvPr>
+          <p:cNvPicPr>
+            <a:picLocks noChangeAspect="1"/>
+          </p:cNvPicPr>
+          <p:nvPr/>
+        </p:nvPicPr>
+        <p:blipFill>
+          <a:blip r:embed="rId3"/>
+          <a:stretch>
+            <a:fillRect/>
+          </a:stretch>
+        </p:blipFill>
+        <p:spPr>
+          <a:xfrm>
+            <a:off x="6196888" y="3222731"/>
+            <a:ext cx="4526886" cy="1513861"/>
+          </a:xfrm>
+          <a:prstGeom prst="rect">
+            <a:avLst/>
+          </a:prstGeom>
+        </p:spPr>
+      </p:pic>
+      <p:pic>
+        <p:nvPicPr>
+          <p:cNvPr id="76" name="Picture 75">
+            <a:extLst>
+              <a:ext uri="{FF2B5EF4-FFF2-40B4-BE49-F238E27FC236}">
+                <a16:creationId xmlns:a16="http://schemas.microsoft.com/office/drawing/2014/main" id="{4DC81C44-7678-57AD-FC8E-90B49F93D432}"/>
+              </a:ext>
+            </a:extLst>
+          </p:cNvPr>
+          <p:cNvPicPr>
+            <a:picLocks noChangeAspect="1"/>
+          </p:cNvPicPr>
+          <p:nvPr/>
+        </p:nvPicPr>
+        <p:blipFill>
+          <a:blip r:embed="rId4"/>
+          <a:stretch>
+            <a:fillRect/>
+          </a:stretch>
+        </p:blipFill>
+        <p:spPr>
+          <a:xfrm>
+            <a:off x="6206032" y="4745832"/>
+            <a:ext cx="4507992" cy="1166198"/>
+          </a:xfrm>
+          <a:prstGeom prst="rect">
+            <a:avLst/>
+          </a:prstGeom>
+        </p:spPr>
+      </p:pic>
     </p:spTree>
   </p:cSld>
   <p:clrMapOvr>
@@ -33563,278 +33553,6 @@
       </p:sp>
       <p:sp>
         <p:nvSpPr>
-          <p:cNvPr id="16" name="Rectangle 15"/>
-          <p:cNvSpPr/>
-          <p:nvPr/>
-        </p:nvSpPr>
-        <p:spPr>
-          <a:xfrm>
-            <a:off x="609904" y="1783080"/>
-            <a:ext cx="6675120" cy="4160520"/>
-          </a:xfrm>
-          <a:prstGeom prst="rect">
-            <a:avLst/>
-          </a:prstGeom>
-          <a:solidFill>
-            <a:srgbClr val="EFE2CC"/>
-          </a:solidFill>
-          <a:ln w="19050">
-            <a:solidFill>
-              <a:srgbClr val="9A6410"/>
-            </a:solidFill>
-          </a:ln>
-          <a:effectLst/>
-        </p:spPr>
-        <p:style>
-          <a:lnRef idx="1">
-            <a:schemeClr val="accent1"/>
-          </a:lnRef>
-          <a:fillRef idx="3">
-            <a:schemeClr val="accent1"/>
-          </a:fillRef>
-          <a:effectRef idx="2">
-            <a:schemeClr val="accent1"/>
-          </a:effectRef>
-          <a:fontRef idx="minor">
-            <a:schemeClr val="lt1"/>
-          </a:fontRef>
-        </p:style>
-        <p:txBody>
-          <a:bodyPr rtlCol="0" anchor="ctr"/>
-          <a:lstStyle/>
-          <a:p>
-            <a:pPr algn="ctr"/>
-            <a:endParaRPr/>
-          </a:p>
-        </p:txBody>
-      </p:sp>
-      <p:sp>
-        <p:nvSpPr>
-          <p:cNvPr id="17" name="Rectangle 16"/>
-          <p:cNvSpPr/>
-          <p:nvPr/>
-        </p:nvSpPr>
-        <p:spPr>
-          <a:xfrm>
-            <a:off x="3289096" y="2057400"/>
-            <a:ext cx="1316736" cy="237744"/>
-          </a:xfrm>
-          <a:prstGeom prst="rect">
-            <a:avLst/>
-          </a:prstGeom>
-          <a:noFill/>
-          <a:ln w="12700">
-            <a:solidFill>
-              <a:srgbClr val="9A6410"/>
-            </a:solidFill>
-          </a:ln>
-          <a:effectLst/>
-        </p:spPr>
-        <p:style>
-          <a:lnRef idx="1">
-            <a:schemeClr val="accent1"/>
-          </a:lnRef>
-          <a:fillRef idx="3">
-            <a:schemeClr val="accent1"/>
-          </a:fillRef>
-          <a:effectRef idx="2">
-            <a:schemeClr val="accent1"/>
-          </a:effectRef>
-          <a:fontRef idx="minor">
-            <a:schemeClr val="lt1"/>
-          </a:fontRef>
-        </p:style>
-        <p:txBody>
-          <a:bodyPr wrap="square" lIns="0" tIns="0" rIns="0" bIns="0" rtlCol="0" anchor="ctr"/>
-          <a:lstStyle/>
-          <a:p>
-            <a:pPr algn="ctr"/>
-            <a:r>
-              <a:rPr sz="700" b="1">
-                <a:solidFill>
-                  <a:srgbClr val="9A6410"/>
-                </a:solidFill>
-                <a:latin typeface="Consolas"/>
-              </a:rPr>
-              <a:t>CAPTURE REQUIRED</a:t>
-            </a:r>
-          </a:p>
-        </p:txBody>
-      </p:sp>
-      <p:sp>
-        <p:nvSpPr>
-          <p:cNvPr id="18" name="TextBox 17"/>
-          <p:cNvSpPr txBox="1"/>
-          <p:nvPr/>
-        </p:nvSpPr>
-        <p:spPr>
-          <a:xfrm>
-            <a:off x="975664" y="2478024"/>
-            <a:ext cx="5943600" cy="457200"/>
-          </a:xfrm>
-          <a:prstGeom prst="rect">
-            <a:avLst/>
-          </a:prstGeom>
-          <a:noFill/>
-        </p:spPr>
-        <p:txBody>
-          <a:bodyPr wrap="square" lIns="0" tIns="0" rIns="0" bIns="0" anchor="t">
-            <a:spAutoFit/>
-          </a:bodyPr>
-          <a:lstStyle/>
-          <a:p>
-            <a:pPr algn="ctr">
-              <a:lnSpc>
-                <a:spcPct val="120000"/>
-              </a:lnSpc>
-            </a:pPr>
-            <a:r>
-              <a:rPr sz="1350" b="1">
-                <a:solidFill>
-                  <a:srgbClr val="2A2419"/>
-                </a:solidFill>
-                <a:latin typeface="Arial"/>
-              </a:rPr>
-              <a:t>An xsim waveform showing a load-use stall and a branch flush</a:t>
-            </a:r>
-          </a:p>
-        </p:txBody>
-      </p:sp>
-      <p:sp>
-        <p:nvSpPr>
-          <p:cNvPr id="19" name="TextBox 18"/>
-          <p:cNvSpPr txBox="1"/>
-          <p:nvPr/>
-        </p:nvSpPr>
-        <p:spPr>
-          <a:xfrm>
-            <a:off x="1067104" y="3044952"/>
-            <a:ext cx="5760720" cy="914400"/>
-          </a:xfrm>
-          <a:prstGeom prst="rect">
-            <a:avLst/>
-          </a:prstGeom>
-          <a:noFill/>
-        </p:spPr>
-        <p:txBody>
-          <a:bodyPr wrap="square" lIns="0" tIns="0" rIns="0" bIns="0" anchor="t">
-            <a:spAutoFit/>
-          </a:bodyPr>
-          <a:lstStyle/>
-          <a:p>
-            <a:pPr algn="ctr">
-              <a:lnSpc>
-                <a:spcPct val="135000"/>
-              </a:lnSpc>
-            </a:pPr>
-            <a:r>
-              <a:rPr sz="1000" b="0">
-                <a:solidFill>
-                  <a:srgbClr val="655C4C"/>
-                </a:solidFill>
-                <a:latin typeface="Arial"/>
-              </a:rPr>
-              <a:t>Record the waveform database on the Windows machine, open it in the Vivado GUI, and screenshot roughly 15 cycles around the stall. Load these signals in order: clk, pc_q, if_id_pc, stall, flush_if, flush_id, fwd_a, fwd_b, trace_valid, trace_pc.</a:t>
-            </a:r>
-          </a:p>
-        </p:txBody>
-      </p:sp>
-      <p:sp>
-        <p:nvSpPr>
-          <p:cNvPr id="20" name="Rectangle 19"/>
-          <p:cNvSpPr/>
-          <p:nvPr/>
-        </p:nvSpPr>
-        <p:spPr>
-          <a:xfrm>
-            <a:off x="929944" y="3886200"/>
-            <a:ext cx="6035040" cy="310896"/>
-          </a:xfrm>
-          <a:prstGeom prst="rect">
-            <a:avLst/>
-          </a:prstGeom>
-          <a:solidFill>
-            <a:srgbClr val="F7F3E8"/>
-          </a:solidFill>
-          <a:ln w="9525">
-            <a:solidFill>
-              <a:srgbClr val="D2C7AF"/>
-            </a:solidFill>
-          </a:ln>
-          <a:effectLst/>
-        </p:spPr>
-        <p:style>
-          <a:lnRef idx="1">
-            <a:schemeClr val="accent1"/>
-          </a:lnRef>
-          <a:fillRef idx="3">
-            <a:schemeClr val="accent1"/>
-          </a:fillRef>
-          <a:effectRef idx="2">
-            <a:schemeClr val="accent1"/>
-          </a:effectRef>
-          <a:fontRef idx="minor">
-            <a:schemeClr val="lt1"/>
-          </a:fontRef>
-        </p:style>
-        <p:txBody>
-          <a:bodyPr wrap="square" lIns="0" tIns="0" rIns="0" bIns="0" rtlCol="0" anchor="ctr"/>
-          <a:lstStyle/>
-          <a:p>
-            <a:pPr algn="ctr"/>
-            <a:r>
-              <a:rPr sz="850" b="0">
-                <a:solidFill>
-                  <a:srgbClr val="2A2419"/>
-                </a:solidFill>
-                <a:latin typeface="Consolas"/>
-              </a:rPr>
-              <a:t>bash sim/run.sh tb_program --plusarg +PROG=asm/hazard/load_use --wave</a:t>
-            </a:r>
-          </a:p>
-        </p:txBody>
-      </p:sp>
-      <p:sp>
-        <p:nvSpPr>
-          <p:cNvPr id="21" name="TextBox 20"/>
-          <p:cNvSpPr txBox="1"/>
-          <p:nvPr/>
-        </p:nvSpPr>
-        <p:spPr>
-          <a:xfrm>
-            <a:off x="975664" y="4306824"/>
-            <a:ext cx="5943600" cy="365760"/>
-          </a:xfrm>
-          <a:prstGeom prst="rect">
-            <a:avLst/>
-          </a:prstGeom>
-          <a:noFill/>
-        </p:spPr>
-        <p:txBody>
-          <a:bodyPr wrap="square" lIns="0" tIns="0" rIns="0" bIns="0" anchor="t">
-            <a:spAutoFit/>
-          </a:bodyPr>
-          <a:lstStyle/>
-          <a:p>
-            <a:pPr algn="ctr">
-              <a:lnSpc>
-                <a:spcPct val="130000"/>
-              </a:lnSpc>
-            </a:pPr>
-            <a:r>
-              <a:rPr sz="900" b="0">
-                <a:solidFill>
-                  <a:srgbClr val="655C4C"/>
-                </a:solidFill>
-                <a:latin typeface="Arial"/>
-              </a:rPr>
-              <a:t>Frame it so stall is visibly high for exactly one cycle while pc_q holds its value.</a:t>
-            </a:r>
-          </a:p>
-        </p:txBody>
-      </p:sp>
-      <p:sp>
-        <p:nvSpPr>
           <p:cNvPr id="22" name="Rectangle 21"/>
           <p:cNvSpPr/>
           <p:nvPr/>
@@ -34616,6 +34334,36 @@
           </a:p>
         </p:txBody>
       </p:sp>
+      <p:pic>
+        <p:nvPicPr>
+          <p:cNvPr id="42" name="Picture 41">
+            <a:extLst>
+              <a:ext uri="{FF2B5EF4-FFF2-40B4-BE49-F238E27FC236}">
+                <a16:creationId xmlns:a16="http://schemas.microsoft.com/office/drawing/2014/main" id="{86819F9E-36F6-3EFA-BCB8-C692F54D6EF6}"/>
+              </a:ext>
+            </a:extLst>
+          </p:cNvPr>
+          <p:cNvPicPr>
+            <a:picLocks noChangeAspect="1"/>
+          </p:cNvPicPr>
+          <p:nvPr/>
+        </p:nvPicPr>
+        <p:blipFill>
+          <a:blip r:embed="rId2"/>
+          <a:stretch>
+            <a:fillRect/>
+          </a:stretch>
+        </p:blipFill>
+        <p:spPr>
+          <a:xfrm>
+            <a:off x="660196" y="2313431"/>
+            <a:ext cx="6794331" cy="3176117"/>
+          </a:xfrm>
+          <a:prstGeom prst="rect">
+            <a:avLst/>
+          </a:prstGeom>
+        </p:spPr>
+      </p:pic>
     </p:spTree>
   </p:cSld>
   <p:clrMapOvr>

</xml_diff>